<commit_message>
Fix jump to Chat after deciding an opportunity card
The sidebar radio sent its choice back as label text, which included
the to-review count. Deciding a card changed the label, so the next
click fell back to Chat and lost that decision. Use one button per
page instead.

Co-Authored-By: Claude Opus 5.5 <noreply@anthropic.com>
</commit_message>
<xml_diff>
--- a/slides/london-office-monitor.pptx
+++ b/slides/london-office-monitor.pptx
@@ -112,19 +112,19 @@
   <p:extLst>
     <p:ext uri="{521415D9-36F7-43E2-AB2F-B90AF26B5E84}">
       <p14:sectionLst xmlns:p14="http://schemas.microsoft.com/office/powerpoint/2010/main">
-        <p14:section name="What it is" id="{935b57f8-acec-f994-1ebe-8f9e7689493d}">
+        <p14:section name="What it is" id="{f4ecf933-0b92-c484-af3f-af1a21604bb2}">
           <p14:sldIdLst>
             <p14:sldId id="256"/>
           </p14:sldIdLst>
         </p14:section>
-        <p14:section name="How it helps" id="{80118479-559f-6d8d-4430-265736b3793f}">
+        <p14:section name="How it helps" id="{ab5c617c-61ed-665d-61f4-30c44960f631}">
           <p14:sldIdLst>
             <p14:sldId id="257"/>
             <p14:sldId id="258"/>
             <p14:sldId id="259"/>
           </p14:sldIdLst>
         </p14:section>
-        <p14:section name="Trust and working together" id="{bf3d3432-8b4a-dda4-c49f-d6566b55e25c}">
+        <p14:section name="Trust and the app" id="{1c89d4d9-5afc-87f6-80b5-d6f5ab6135f4}">
           <p14:sldIdLst>
             <p14:sldId id="260"/>
             <p14:sldId id="261"/>
@@ -622,7 +622,7 @@
           <a:p>
             <a:r>
               <a:rPr lang="en-US" dirty="0"/>
-              <a:t>First, time. To compare what six brokers say about one figure, an analyst opens six reports, finds the figure in each, and checks how each broker defines it. The Monitor does it in about 15 seconds and links every figure to its source. The weekly brief takes about a minute to draft, and the opportunity scan about two. Each costs a few cents of AI usage. These times come from our test runs on 24 and 25 October. We have not yet measured how long the same work takes the team by hand; that is one of the things we ask the team for on the last slide.</a:t>
+              <a:t>First, time. To compare what six brokers say about one figure, an analyst opens six reports, finds the figure in each, and checks how each broker defines it. The Monitor does it in about 15 seconds and links every figure to its source. The weekly brief takes about a minute to draft, and the opportunity scan about two. Each costs a few cents of AI usage. These times come from our test runs on 24 and 25 October. We have not yet measured how long the same work takes the team by hand, so that comparison is still to come.</a:t>
             </a:r>
             <a:endParaRPr lang="en-US" dirty="0"/>
           </a:p>
@@ -974,7 +974,7 @@
           <a:p>
             <a:r>
               <a:rPr lang="en-US" dirty="0"/>
-              <a:t>For this to work beyond a demo, we need four things from the business team. First, data readiness: our real mandate, asset details and past decisions in place of the illustrative and mock examples; licences for the broker reports the team already receives; and the past figures in the team's spreadsheets, so trends have history. Second, your know-how: how each task is done today, which brokers and measures you trust when they disagree, and what a good brief or a good lead looks like. That becomes the tool's playbooks. Third, ways to judge it: real questions with the right answers, leads you would and wouldn't pursue, and how long the work takes by hand today, so we can measure quality and time saved before anyone relies on it. Fourth, time and sign-off: a few analysts to use it and give feedback, compliance sign-off on how our data is used with AI models, and secure hosting with login. Internal documents need an access and data-residency review first, because the passages used in an answer are sent to the AI model provider.</a:t>
+              <a:t>To finish, a quick look at the app itself. In Chat, you ask a question in plain words; here, how City prime rent has moved, and every broker's figure comes back on a chart with a link to each source. The weekly brief is one click: it drafts what changed, the news themes, rates and what it means for our buildings. Opportunities is where the scan's leads arrive: the analyst approves or rejects each one under To review, and approved ones are shared with the team under Approved. Everything shown is the demo snapshot from 24 October 2026, and the card shown is marked as a demo example.</a:t>
             </a:r>
             <a:endParaRPr lang="en-US" dirty="0"/>
           </a:p>
@@ -7484,7 +7484,7 @@
                 <a:ea typeface="Calibri" pitchFamily="34" charset="-122"/>
                 <a:cs typeface="Calibri" pitchFamily="34" charset="-120"/>
               </a:rPr>
-              <a:t>WORKING TOGETHER</a:t>
+              <a:t>IN THE APP</a:t>
             </a:r>
             <a:endParaRPr lang="en-US" sz="1200" dirty="0"/>
           </a:p>
@@ -7525,7 +7525,7 @@
                 <a:ea typeface="Cambria" pitchFamily="34" charset="-122"/>
                 <a:cs typeface="Cambria" pitchFamily="34" charset="-120"/>
               </a:rPr>
-              <a:t>What we need from the business team</a:t>
+              <a:t>A quick tour of the app</a:t>
             </a:r>
             <a:endParaRPr lang="en-US" sz="3000" dirty="0"/>
           </a:p>
@@ -7533,74 +7533,39 @@
       </p:sp>
       <p:sp>
         <p:nvSpPr>
-          <p:cNvPr id="4" name="Why it matters"/>
-          <p:cNvSpPr txBox="1"/>
-          <p:nvPr/>
-        </p:nvSpPr>
-        <p:spPr>
-          <a:xfrm>
-            <a:off x="457200" y="1261872"/>
-            <a:ext cx="8229600" cy="292608"/>
-          </a:xfrm>
-          <a:prstGeom prst="rect">
-            <a:avLst/>
-          </a:prstGeom>
-          <a:noFill/>
-          <a:ln/>
-        </p:spPr>
-        <p:txBody>
-          <a:bodyPr wrap="square" lIns="0" tIns="0" rIns="0" bIns="0" rtlCol="0" anchor="t"/>
-          <a:lstStyle/>
-          <a:p>
-            <a:pPr indent="0" marL="0">
-              <a:buNone/>
-            </a:pPr>
-            <a:r>
-              <a:rPr lang="en-US" sz="1500" i="1" dirty="0">
-                <a:solidFill>
-                  <a:schemeClr val="bg2"/>
-                </a:solidFill>
-              </a:rPr>
-              <a:t>An AI tool is only as good as the data and know-how behind it.</a:t>
-            </a:r>
-            <a:endParaRPr lang="en-US" sz="1500" dirty="0"/>
-          </a:p>
-        </p:txBody>
-      </p:sp>
-      <p:sp>
-        <p:nvSpPr>
-          <p:cNvPr id="5" name="Data readiness card"/>
+          <p:cNvPr id="4" name="Chat screenshot frame"/>
           <p:cNvSpPr/>
           <p:nvPr/>
         </p:nvSpPr>
         <p:spPr>
           <a:xfrm>
-            <a:off x="457200" y="1691640"/>
-            <a:ext cx="4023360" cy="1325880"/>
-          </a:xfrm>
-          <a:prstGeom prst="roundRect">
-            <a:avLst>
-              <a:gd name="adj" fmla="val 5517"/>
-            </a:avLst>
+            <a:off x="457200" y="1417320"/>
+            <a:ext cx="2596896" cy="1947993"/>
+          </a:xfrm>
+          <a:prstGeom prst="rect">
+            <a:avLst/>
           </a:prstGeom>
           <a:solidFill>
-            <a:schemeClr val="bg1">
-              <a:alpha val="12000"/>
-            </a:schemeClr>
+            <a:schemeClr val="bg1"/>
           </a:solidFill>
           <a:ln w="12700">
             <a:solidFill>
-              <a:schemeClr val="bg1">
-                <a:alpha val="12000"/>
-              </a:schemeClr>
+              <a:schemeClr val="bg1"/>
             </a:solidFill>
             <a:prstDash val="solid"/>
           </a:ln>
+          <a:effectLst>
+            <a:outerShdw sx="100000" sy="100000" kx="0" ky="0" algn="bl" rotWithShape="0" blurRad="76200" dist="25400" dir="5400000">
+              <a:srgbClr val="000000">
+                <a:alpha val="25000"/>
+              </a:srgbClr>
+            </a:outerShdw>
+          </a:effectLst>
         </p:spPr>
       </p:sp>
       <p:pic>
         <p:nvPicPr>
-          <p:cNvPr id="6" name="Image 0" descr="Data readiness icon">    </p:cNvPr>
+          <p:cNvPr id="5" name="Image 0" descr="Chat: City Core prime rent by broker on a chart, with its sources">    </p:cNvPr>
           <p:cNvPicPr>
             <a:picLocks noChangeAspect="1"/>
           </p:cNvPicPr>
@@ -7614,160 +7579,17 @@
         </p:blipFill>
         <p:spPr>
           <a:xfrm>
-            <a:off x="658368" y="1847088"/>
-            <a:ext cx="292608" cy="292608"/>
+            <a:off x="457200" y="1417320"/>
+            <a:ext cx="2596896" cy="1947993"/>
           </a:xfrm>
           <a:prstGeom prst="rect">
             <a:avLst/>
           </a:prstGeom>
         </p:spPr>
       </p:pic>
-      <p:sp>
-        <p:nvSpPr>
-          <p:cNvPr id="7" name="Text 4"/>
-          <p:cNvSpPr txBox="1"/>
-          <p:nvPr/>
-        </p:nvSpPr>
-        <p:spPr>
-          <a:xfrm>
-            <a:off x="1078992" y="1828800"/>
-            <a:ext cx="3200400" cy="329184"/>
-          </a:xfrm>
-          <a:prstGeom prst="rect">
-            <a:avLst/>
-          </a:prstGeom>
-          <a:noFill/>
-          <a:ln/>
-        </p:spPr>
-        <p:txBody>
-          <a:bodyPr wrap="square" lIns="0" tIns="0" rIns="0" bIns="0" rtlCol="0" anchor="ctr"/>
-          <a:lstStyle/>
-          <a:p>
-            <a:pPr indent="0" marL="0">
-              <a:buNone/>
-            </a:pPr>
-            <a:r>
-              <a:rPr lang="en-US" sz="1700" b="1" dirty="0">
-                <a:solidFill>
-                  <a:schemeClr val="bg1"/>
-                </a:solidFill>
-              </a:rPr>
-              <a:t>Data readiness</a:t>
-            </a:r>
-            <a:endParaRPr lang="en-US" sz="1700" dirty="0"/>
-          </a:p>
-        </p:txBody>
-      </p:sp>
-      <p:sp>
-        <p:nvSpPr>
-          <p:cNvPr id="8" name="Text 5"/>
-          <p:cNvSpPr txBox="1"/>
-          <p:nvPr/>
-        </p:nvSpPr>
-        <p:spPr>
-          <a:xfrm>
-            <a:off x="658368" y="2240280"/>
-            <a:ext cx="3703320" cy="731520"/>
-          </a:xfrm>
-          <a:prstGeom prst="rect">
-            <a:avLst/>
-          </a:prstGeom>
-          <a:noFill/>
-          <a:ln/>
-        </p:spPr>
-        <p:txBody>
-          <a:bodyPr wrap="square" lIns="0" tIns="0" rIns="0" bIns="0" rtlCol="0" anchor="t"/>
-          <a:lstStyle/>
-          <a:p>
-            <a:pPr marL="177800" indent="-177800">
-              <a:spcAft>
-                <a:spcPts val="200"/>
-              </a:spcAft>
-              <a:buSzPct val="100000"/>
-              <a:buChar char="•"/>
-            </a:pPr>
-            <a:r>
-              <a:rPr lang="en-US" sz="1400" dirty="0">
-                <a:solidFill>
-                  <a:schemeClr val="bg2"/>
-                </a:solidFill>
-              </a:rPr>
-              <a:t>Real mandate, assets and past decisions</a:t>
-            </a:r>
-            <a:endParaRPr lang="en-US" sz="1400" dirty="0"/>
-          </a:p>
-          <a:p>
-            <a:pPr marL="177800" indent="-177800">
-              <a:spcAft>
-                <a:spcPts val="200"/>
-              </a:spcAft>
-              <a:buSzPct val="100000"/>
-              <a:buChar char="•"/>
-            </a:pPr>
-            <a:r>
-              <a:rPr lang="en-US" sz="1400" dirty="0">
-                <a:solidFill>
-                  <a:schemeClr val="bg2"/>
-                </a:solidFill>
-              </a:rPr>
-              <a:t>Licences for broker reports we receive</a:t>
-            </a:r>
-            <a:endParaRPr lang="en-US" sz="1400" dirty="0"/>
-          </a:p>
-          <a:p>
-            <a:pPr marL="177800" indent="-177800">
-              <a:spcAft>
-                <a:spcPts val="200"/>
-              </a:spcAft>
-              <a:buSzPct val="100000"/>
-              <a:buChar char="•"/>
-            </a:pPr>
-            <a:r>
-              <a:rPr lang="en-US" sz="1400" dirty="0">
-                <a:solidFill>
-                  <a:schemeClr val="bg2"/>
-                </a:solidFill>
-              </a:rPr>
-              <a:t>Past figures from your spreadsheets</a:t>
-            </a:r>
-            <a:endParaRPr lang="en-US" sz="1400" dirty="0"/>
-          </a:p>
-        </p:txBody>
-      </p:sp>
-      <p:sp>
-        <p:nvSpPr>
-          <p:cNvPr id="9" name="Your know-how card"/>
-          <p:cNvSpPr/>
-          <p:nvPr/>
-        </p:nvSpPr>
-        <p:spPr>
-          <a:xfrm>
-            <a:off x="4663440" y="1691640"/>
-            <a:ext cx="4023360" cy="1325880"/>
-          </a:xfrm>
-          <a:prstGeom prst="roundRect">
-            <a:avLst>
-              <a:gd name="adj" fmla="val 5517"/>
-            </a:avLst>
-          </a:prstGeom>
-          <a:solidFill>
-            <a:schemeClr val="bg1">
-              <a:alpha val="12000"/>
-            </a:schemeClr>
-          </a:solidFill>
-          <a:ln w="12700">
-            <a:solidFill>
-              <a:schemeClr val="bg1">
-                <a:alpha val="12000"/>
-              </a:schemeClr>
-            </a:solidFill>
-            <a:prstDash val="solid"/>
-          </a:ln>
-        </p:spPr>
-      </p:sp>
       <p:pic>
         <p:nvPicPr>
-          <p:cNvPr id="10" name="Image 1" descr="Your know-how icon">    </p:cNvPr>
+          <p:cNvPr id="6" name="Image 1" descr="Chat icon">    </p:cNvPr>
           <p:cNvPicPr>
             <a:picLocks noChangeAspect="1"/>
           </p:cNvPicPr>
@@ -7781,8 +7603,8 @@
         </p:blipFill>
         <p:spPr>
           <a:xfrm>
-            <a:off x="4864608" y="1847088"/>
-            <a:ext cx="292608" cy="292608"/>
+            <a:off x="457200" y="3566481"/>
+            <a:ext cx="274320" cy="274320"/>
           </a:xfrm>
           <a:prstGeom prst="rect">
             <a:avLst/>
@@ -7791,14 +7613,14 @@
       </p:pic>
       <p:sp>
         <p:nvSpPr>
-          <p:cNvPr id="11" name="Text 7"/>
-          <p:cNvSpPr txBox="1"/>
-          <p:nvPr/>
-        </p:nvSpPr>
-        <p:spPr>
-          <a:xfrm>
-            <a:off x="5285232" y="1828800"/>
-            <a:ext cx="3200400" cy="329184"/>
+          <p:cNvPr id="7" name="Text 3"/>
+          <p:cNvSpPr txBox="1"/>
+          <p:nvPr/>
+        </p:nvSpPr>
+        <p:spPr>
+          <a:xfrm>
+            <a:off x="841248" y="3529905"/>
+            <a:ext cx="2212848" cy="347472"/>
           </a:xfrm>
           <a:prstGeom prst="rect">
             <a:avLst/>
@@ -7819,7 +7641,7 @@
                   <a:schemeClr val="bg1"/>
                 </a:solidFill>
               </a:rPr>
-              <a:t>Your know-how</a:t>
+              <a:t>Chat</a:t>
             </a:r>
             <a:endParaRPr lang="en-US" sz="1700" dirty="0"/>
           </a:p>
@@ -7827,14 +7649,14 @@
       </p:sp>
       <p:sp>
         <p:nvSpPr>
-          <p:cNvPr id="12" name="Text 8"/>
-          <p:cNvSpPr txBox="1"/>
-          <p:nvPr/>
-        </p:nvSpPr>
-        <p:spPr>
-          <a:xfrm>
-            <a:off x="4864608" y="2240280"/>
-            <a:ext cx="3703320" cy="731520"/>
+          <p:cNvPr id="8" name="Text 4"/>
+          <p:cNvSpPr txBox="1"/>
+          <p:nvPr/>
+        </p:nvSpPr>
+        <p:spPr>
+          <a:xfrm>
+            <a:off x="457200" y="3932241"/>
+            <a:ext cx="2596896" cy="502920"/>
           </a:xfrm>
           <a:prstGeom prst="rect">
             <a:avLst/>
@@ -7846,12 +7668,8 @@
           <a:bodyPr wrap="square" lIns="0" tIns="0" rIns="0" bIns="0" rtlCol="0" anchor="t"/>
           <a:lstStyle/>
           <a:p>
-            <a:pPr marL="177800" indent="-177800">
-              <a:spcAft>
-                <a:spcPts val="200"/>
-              </a:spcAft>
-              <a:buSzPct val="100000"/>
-              <a:buChar char="•"/>
+            <a:pPr indent="0" marL="0">
+              <a:buNone/>
             </a:pPr>
             <a:r>
               <a:rPr lang="en-US" sz="1400" dirty="0">
@@ -7859,82 +7677,47 @@
                   <a:schemeClr val="bg2"/>
                 </a:solidFill>
               </a:rPr>
-              <a:t>How each task is done today</a:t>
+              <a:t>Ask anything: every broker's figure, a chart and the sources</a:t>
             </a:r>
             <a:endParaRPr lang="en-US" sz="1400" dirty="0"/>
           </a:p>
-          <a:p>
-            <a:pPr marL="177800" indent="-177800">
-              <a:spcAft>
-                <a:spcPts val="200"/>
-              </a:spcAft>
-              <a:buSzPct val="100000"/>
-              <a:buChar char="•"/>
-            </a:pPr>
-            <a:r>
-              <a:rPr lang="en-US" sz="1400" dirty="0">
-                <a:solidFill>
-                  <a:schemeClr val="bg2"/>
-                </a:solidFill>
-              </a:rPr>
-              <a:t>Which brokers and measures you trust</a:t>
-            </a:r>
-            <a:endParaRPr lang="en-US" sz="1400" dirty="0"/>
-          </a:p>
-          <a:p>
-            <a:pPr marL="177800" indent="-177800">
-              <a:spcAft>
-                <a:spcPts val="200"/>
-              </a:spcAft>
-              <a:buSzPct val="100000"/>
-              <a:buChar char="•"/>
-            </a:pPr>
-            <a:r>
-              <a:rPr lang="en-US" sz="1400" dirty="0">
-                <a:solidFill>
-                  <a:schemeClr val="bg2"/>
-                </a:solidFill>
-              </a:rPr>
-              <a:t>What a good brief or lead looks like</a:t>
-            </a:r>
-            <a:endParaRPr lang="en-US" sz="1400" dirty="0"/>
-          </a:p>
-        </p:txBody>
-      </p:sp>
-      <p:sp>
-        <p:nvSpPr>
-          <p:cNvPr id="13" name="How we'll judge it card"/>
+        </p:txBody>
+      </p:sp>
+      <p:sp>
+        <p:nvSpPr>
+          <p:cNvPr id="9" name="Weekly brief screenshot frame"/>
           <p:cNvSpPr/>
           <p:nvPr/>
         </p:nvSpPr>
         <p:spPr>
           <a:xfrm>
-            <a:off x="457200" y="3154680"/>
-            <a:ext cx="4023360" cy="1325880"/>
-          </a:xfrm>
-          <a:prstGeom prst="roundRect">
-            <a:avLst>
-              <a:gd name="adj" fmla="val 5517"/>
-            </a:avLst>
+            <a:off x="3273552" y="1417320"/>
+            <a:ext cx="2596896" cy="1947672"/>
+          </a:xfrm>
+          <a:prstGeom prst="rect">
+            <a:avLst/>
           </a:prstGeom>
           <a:solidFill>
-            <a:schemeClr val="bg1">
-              <a:alpha val="12000"/>
-            </a:schemeClr>
+            <a:schemeClr val="bg1"/>
           </a:solidFill>
           <a:ln w="12700">
             <a:solidFill>
-              <a:schemeClr val="bg1">
-                <a:alpha val="12000"/>
-              </a:schemeClr>
+              <a:schemeClr val="bg1"/>
             </a:solidFill>
             <a:prstDash val="solid"/>
           </a:ln>
+          <a:effectLst>
+            <a:outerShdw sx="100000" sy="100000" kx="0" ky="0" algn="bl" rotWithShape="0" blurRad="76200" dist="25400" dir="5400000">
+              <a:srgbClr val="000000">
+                <a:alpha val="25000"/>
+              </a:srgbClr>
+            </a:outerShdw>
+          </a:effectLst>
         </p:spPr>
       </p:sp>
       <p:pic>
         <p:nvPicPr>
-          <p:cNvPr id="14" name="Image 2" descr="How we'll judge it icon">    </p:cNvPr>
+          <p:cNvPr id="10" name="Image 2" descr="The weekly brief: what changed and the news themes, each linked to its source">    </p:cNvPr>
           <p:cNvPicPr>
             <a:picLocks noChangeAspect="1"/>
           </p:cNvPicPr>
@@ -7948,160 +7731,17 @@
         </p:blipFill>
         <p:spPr>
           <a:xfrm>
-            <a:off x="658368" y="3310128"/>
-            <a:ext cx="292608" cy="292608"/>
+            <a:off x="3273552" y="1417320"/>
+            <a:ext cx="2596896" cy="1947672"/>
           </a:xfrm>
           <a:prstGeom prst="rect">
             <a:avLst/>
           </a:prstGeom>
         </p:spPr>
       </p:pic>
-      <p:sp>
-        <p:nvSpPr>
-          <p:cNvPr id="15" name="Text 10"/>
-          <p:cNvSpPr txBox="1"/>
-          <p:nvPr/>
-        </p:nvSpPr>
-        <p:spPr>
-          <a:xfrm>
-            <a:off x="1078992" y="3291840"/>
-            <a:ext cx="3200400" cy="329184"/>
-          </a:xfrm>
-          <a:prstGeom prst="rect">
-            <a:avLst/>
-          </a:prstGeom>
-          <a:noFill/>
-          <a:ln/>
-        </p:spPr>
-        <p:txBody>
-          <a:bodyPr wrap="square" lIns="0" tIns="0" rIns="0" bIns="0" rtlCol="0" anchor="ctr"/>
-          <a:lstStyle/>
-          <a:p>
-            <a:pPr indent="0" marL="0">
-              <a:buNone/>
-            </a:pPr>
-            <a:r>
-              <a:rPr lang="en-US" sz="1700" b="1" dirty="0">
-                <a:solidFill>
-                  <a:schemeClr val="bg1"/>
-                </a:solidFill>
-              </a:rPr>
-              <a:t>How we'll judge it</a:t>
-            </a:r>
-            <a:endParaRPr lang="en-US" sz="1700" dirty="0"/>
-          </a:p>
-        </p:txBody>
-      </p:sp>
-      <p:sp>
-        <p:nvSpPr>
-          <p:cNvPr id="16" name="Text 11"/>
-          <p:cNvSpPr txBox="1"/>
-          <p:nvPr/>
-        </p:nvSpPr>
-        <p:spPr>
-          <a:xfrm>
-            <a:off x="658368" y="3703320"/>
-            <a:ext cx="3703320" cy="731520"/>
-          </a:xfrm>
-          <a:prstGeom prst="rect">
-            <a:avLst/>
-          </a:prstGeom>
-          <a:noFill/>
-          <a:ln/>
-        </p:spPr>
-        <p:txBody>
-          <a:bodyPr wrap="square" lIns="0" tIns="0" rIns="0" bIns="0" rtlCol="0" anchor="t"/>
-          <a:lstStyle/>
-          <a:p>
-            <a:pPr marL="177800" indent="-177800">
-              <a:spcAft>
-                <a:spcPts val="200"/>
-              </a:spcAft>
-              <a:buSzPct val="100000"/>
-              <a:buChar char="•"/>
-            </a:pPr>
-            <a:r>
-              <a:rPr lang="en-US" sz="1400" dirty="0">
-                <a:solidFill>
-                  <a:schemeClr val="bg2"/>
-                </a:solidFill>
-              </a:rPr>
-              <a:t>Real questions, with the right answers</a:t>
-            </a:r>
-            <a:endParaRPr lang="en-US" sz="1400" dirty="0"/>
-          </a:p>
-          <a:p>
-            <a:pPr marL="177800" indent="-177800">
-              <a:spcAft>
-                <a:spcPts val="200"/>
-              </a:spcAft>
-              <a:buSzPct val="100000"/>
-              <a:buChar char="•"/>
-            </a:pPr>
-            <a:r>
-              <a:rPr lang="en-US" sz="1400" dirty="0">
-                <a:solidFill>
-                  <a:schemeClr val="bg2"/>
-                </a:solidFill>
-              </a:rPr>
-              <a:t>Leads you would and wouldn't pursue</a:t>
-            </a:r>
-            <a:endParaRPr lang="en-US" sz="1400" dirty="0"/>
-          </a:p>
-          <a:p>
-            <a:pPr marL="177800" indent="-177800">
-              <a:spcAft>
-                <a:spcPts val="200"/>
-              </a:spcAft>
-              <a:buSzPct val="100000"/>
-              <a:buChar char="•"/>
-            </a:pPr>
-            <a:r>
-              <a:rPr lang="en-US" sz="1400" dirty="0">
-                <a:solidFill>
-                  <a:schemeClr val="bg2"/>
-                </a:solidFill>
-              </a:rPr>
-              <a:t>How long tasks take by hand today</a:t>
-            </a:r>
-            <a:endParaRPr lang="en-US" sz="1400" dirty="0"/>
-          </a:p>
-        </p:txBody>
-      </p:sp>
-      <p:sp>
-        <p:nvSpPr>
-          <p:cNvPr id="17" name="Time and sign-off card"/>
-          <p:cNvSpPr/>
-          <p:nvPr/>
-        </p:nvSpPr>
-        <p:spPr>
-          <a:xfrm>
-            <a:off x="4663440" y="3154680"/>
-            <a:ext cx="4023360" cy="1325880"/>
-          </a:xfrm>
-          <a:prstGeom prst="roundRect">
-            <a:avLst>
-              <a:gd name="adj" fmla="val 5517"/>
-            </a:avLst>
-          </a:prstGeom>
-          <a:solidFill>
-            <a:schemeClr val="bg1">
-              <a:alpha val="12000"/>
-            </a:schemeClr>
-          </a:solidFill>
-          <a:ln w="12700">
-            <a:solidFill>
-              <a:schemeClr val="bg1">
-                <a:alpha val="12000"/>
-              </a:schemeClr>
-            </a:solidFill>
-            <a:prstDash val="solid"/>
-          </a:ln>
-        </p:spPr>
-      </p:sp>
       <p:pic>
         <p:nvPicPr>
-          <p:cNvPr id="18" name="Image 3" descr="Time and sign-off icon">    </p:cNvPr>
+          <p:cNvPr id="11" name="Image 3" descr="Weekly brief icon">    </p:cNvPr>
           <p:cNvPicPr>
             <a:picLocks noChangeAspect="1"/>
           </p:cNvPicPr>
@@ -8115,8 +7755,8 @@
         </p:blipFill>
         <p:spPr>
           <a:xfrm>
-            <a:off x="4864608" y="3310128"/>
-            <a:ext cx="292608" cy="292608"/>
+            <a:off x="3273552" y="3566160"/>
+            <a:ext cx="274320" cy="274320"/>
           </a:xfrm>
           <a:prstGeom prst="rect">
             <a:avLst/>
@@ -8125,14 +7765,14 @@
       </p:pic>
       <p:sp>
         <p:nvSpPr>
-          <p:cNvPr id="19" name="Text 13"/>
-          <p:cNvSpPr txBox="1"/>
-          <p:nvPr/>
-        </p:nvSpPr>
-        <p:spPr>
-          <a:xfrm>
-            <a:off x="5285232" y="3291840"/>
-            <a:ext cx="3200400" cy="329184"/>
+          <p:cNvPr id="12" name="Text 6"/>
+          <p:cNvSpPr txBox="1"/>
+          <p:nvPr/>
+        </p:nvSpPr>
+        <p:spPr>
+          <a:xfrm>
+            <a:off x="3657600" y="3529584"/>
+            <a:ext cx="2212848" cy="347472"/>
           </a:xfrm>
           <a:prstGeom prst="rect">
             <a:avLst/>
@@ -8153,7 +7793,7 @@
                   <a:schemeClr val="bg1"/>
                 </a:solidFill>
               </a:rPr>
-              <a:t>Time and sign-off</a:t>
+              <a:t>Weekly brief</a:t>
             </a:r>
             <a:endParaRPr lang="en-US" sz="1700" dirty="0"/>
           </a:p>
@@ -8161,14 +7801,14 @@
       </p:sp>
       <p:sp>
         <p:nvSpPr>
-          <p:cNvPr id="20" name="Text 14"/>
-          <p:cNvSpPr txBox="1"/>
-          <p:nvPr/>
-        </p:nvSpPr>
-        <p:spPr>
-          <a:xfrm>
-            <a:off x="4864608" y="3703320"/>
-            <a:ext cx="3703320" cy="731520"/>
+          <p:cNvPr id="13" name="Text 7"/>
+          <p:cNvSpPr txBox="1"/>
+          <p:nvPr/>
+        </p:nvSpPr>
+        <p:spPr>
+          <a:xfrm>
+            <a:off x="3273552" y="3931920"/>
+            <a:ext cx="2596896" cy="502920"/>
           </a:xfrm>
           <a:prstGeom prst="rect">
             <a:avLst/>
@@ -8180,12 +7820,8 @@
           <a:bodyPr wrap="square" lIns="0" tIns="0" rIns="0" bIns="0" rtlCol="0" anchor="t"/>
           <a:lstStyle/>
           <a:p>
-            <a:pPr marL="177800" indent="-177800">
-              <a:spcAft>
-                <a:spcPts val="200"/>
-              </a:spcAft>
-              <a:buSzPct val="100000"/>
-              <a:buChar char="•"/>
+            <a:pPr indent="0" marL="0">
+              <a:buNone/>
             </a:pPr>
             <a:r>
               <a:rPr lang="en-US" sz="1400" dirty="0">
@@ -8193,17 +7829,151 @@
                   <a:schemeClr val="bg2"/>
                 </a:solidFill>
               </a:rPr>
-              <a:t>Analysts to try it and give feedback</a:t>
+              <a:t>Read a draft of what changed and what it means for us</a:t>
             </a:r>
             <a:endParaRPr lang="en-US" sz="1400" dirty="0"/>
           </a:p>
-          <a:p>
-            <a:pPr marL="177800" indent="-177800">
-              <a:spcAft>
-                <a:spcPts val="200"/>
-              </a:spcAft>
-              <a:buSzPct val="100000"/>
-              <a:buChar char="•"/>
+        </p:txBody>
+      </p:sp>
+      <p:sp>
+        <p:nvSpPr>
+          <p:cNvPr id="14" name="Opportunities screenshot frame"/>
+          <p:cNvSpPr/>
+          <p:nvPr/>
+        </p:nvSpPr>
+        <p:spPr>
+          <a:xfrm>
+            <a:off x="6089904" y="1417320"/>
+            <a:ext cx="2596896" cy="1947345"/>
+          </a:xfrm>
+          <a:prstGeom prst="rect">
+            <a:avLst/>
+          </a:prstGeom>
+          <a:solidFill>
+            <a:schemeClr val="bg1"/>
+          </a:solidFill>
+          <a:ln w="12700">
+            <a:solidFill>
+              <a:schemeClr val="bg1"/>
+            </a:solidFill>
+            <a:prstDash val="solid"/>
+          </a:ln>
+          <a:effectLst>
+            <a:outerShdw sx="100000" sy="100000" kx="0" ky="0" algn="bl" rotWithShape="0" blurRad="76200" dist="25400" dir="5400000">
+              <a:srgbClr val="000000">
+                <a:alpha val="25000"/>
+              </a:srgbClr>
+            </a:outerShdw>
+          </a:effectLst>
+        </p:spPr>
+      </p:sp>
+      <p:pic>
+        <p:nvPicPr>
+          <p:cNvPr id="15" name="Image 4" descr="The Opportunities page: an approved opportunity card, marked as a demo example">    </p:cNvPr>
+          <p:cNvPicPr>
+            <a:picLocks noChangeAspect="1"/>
+          </p:cNvPicPr>
+          <p:nvPr/>
+        </p:nvPicPr>
+        <p:blipFill>
+          <a:blip r:embed="rId5"/>
+          <a:stretch>
+            <a:fillRect/>
+          </a:stretch>
+        </p:blipFill>
+        <p:spPr>
+          <a:xfrm>
+            <a:off x="6089904" y="1417320"/>
+            <a:ext cx="2596896" cy="1947345"/>
+          </a:xfrm>
+          <a:prstGeom prst="rect">
+            <a:avLst/>
+          </a:prstGeom>
+        </p:spPr>
+      </p:pic>
+      <p:pic>
+        <p:nvPicPr>
+          <p:cNvPr id="16" name="Image 5" descr="Opportunities icon">    </p:cNvPr>
+          <p:cNvPicPr>
+            <a:picLocks noChangeAspect="1"/>
+          </p:cNvPicPr>
+          <p:nvPr/>
+        </p:nvPicPr>
+        <p:blipFill>
+          <a:blip r:embed="rId6"/>
+          <a:stretch>
+            <a:fillRect/>
+          </a:stretch>
+        </p:blipFill>
+        <p:spPr>
+          <a:xfrm>
+            <a:off x="6089904" y="3565833"/>
+            <a:ext cx="274320" cy="274320"/>
+          </a:xfrm>
+          <a:prstGeom prst="rect">
+            <a:avLst/>
+          </a:prstGeom>
+        </p:spPr>
+      </p:pic>
+      <p:sp>
+        <p:nvSpPr>
+          <p:cNvPr id="17" name="Text 9"/>
+          <p:cNvSpPr txBox="1"/>
+          <p:nvPr/>
+        </p:nvSpPr>
+        <p:spPr>
+          <a:xfrm>
+            <a:off x="6473952" y="3529257"/>
+            <a:ext cx="2212848" cy="347472"/>
+          </a:xfrm>
+          <a:prstGeom prst="rect">
+            <a:avLst/>
+          </a:prstGeom>
+          <a:noFill/>
+          <a:ln/>
+        </p:spPr>
+        <p:txBody>
+          <a:bodyPr wrap="square" lIns="0" tIns="0" rIns="0" bIns="0" rtlCol="0" anchor="ctr"/>
+          <a:lstStyle/>
+          <a:p>
+            <a:pPr indent="0" marL="0">
+              <a:buNone/>
+            </a:pPr>
+            <a:r>
+              <a:rPr lang="en-US" sz="1700" b="1" dirty="0">
+                <a:solidFill>
+                  <a:schemeClr val="bg1"/>
+                </a:solidFill>
+              </a:rPr>
+              <a:t>Opportunities</a:t>
+            </a:r>
+            <a:endParaRPr lang="en-US" sz="1700" dirty="0"/>
+          </a:p>
+        </p:txBody>
+      </p:sp>
+      <p:sp>
+        <p:nvSpPr>
+          <p:cNvPr id="18" name="Text 10"/>
+          <p:cNvSpPr txBox="1"/>
+          <p:nvPr/>
+        </p:nvSpPr>
+        <p:spPr>
+          <a:xfrm>
+            <a:off x="6089904" y="3931593"/>
+            <a:ext cx="2596896" cy="502920"/>
+          </a:xfrm>
+          <a:prstGeom prst="rect">
+            <a:avLst/>
+          </a:prstGeom>
+          <a:noFill/>
+          <a:ln/>
+        </p:spPr>
+        <p:txBody>
+          <a:bodyPr wrap="square" lIns="0" tIns="0" rIns="0" bIns="0" rtlCol="0" anchor="t"/>
+          <a:lstStyle/>
+          <a:p>
+            <a:pPr indent="0" marL="0">
+              <a:buNone/>
             </a:pPr>
             <a:r>
               <a:rPr lang="en-US" sz="1400" dirty="0">
@@ -8211,25 +7981,7 @@
                   <a:schemeClr val="bg2"/>
                 </a:solidFill>
               </a:rPr>
-              <a:t>Compliance sign-off on AI and data use</a:t>
-            </a:r>
-            <a:endParaRPr lang="en-US" sz="1400" dirty="0"/>
-          </a:p>
-          <a:p>
-            <a:pPr marL="177800" indent="-177800">
-              <a:spcAft>
-                <a:spcPts val="200"/>
-              </a:spcAft>
-              <a:buSzPct val="100000"/>
-              <a:buChar char="•"/>
-            </a:pPr>
-            <a:r>
-              <a:rPr lang="en-US" sz="1400" dirty="0">
-                <a:solidFill>
-                  <a:schemeClr val="bg2"/>
-                </a:solidFill>
-              </a:rPr>
-              <a:t>Secure hosting with login</a:t>
+              <a:t>Discover leads; approved ones are shared with the team</a:t>
             </a:r>
             <a:endParaRPr lang="en-US" sz="1400" dirty="0"/>
           </a:p>

</xml_diff>